<commit_message>
Update notebook, presentation slides, and README
</commit_message>
<xml_diff>
--- a/Project_presentation.pptx
+++ b/Project_presentation.pptx
@@ -8887,7 +8887,11 @@
             <a:pPr lvl="0"/>
             <a:r>
               <a:rPr lang="en-US" sz="2000" dirty="0"/>
-              <a:t>The characteristics and behavioral outcome of the gym members </a:t>
+              <a:t>Customer profile and churn </a:t>
+            </a:r>
+            <a:r>
+              <a:rPr lang="en-US" sz="2000" dirty="0" err="1"/>
+              <a:t>behaviour</a:t>
             </a:r>
             <a:endParaRPr sz="2000" b="1" dirty="0">
               <a:latin typeface="Assistant"/>

</xml_diff>

<commit_message>
Update presentation and notebook
</commit_message>
<xml_diff>
--- a/Project_presentation.pptx
+++ b/Project_presentation.pptx
@@ -5,7 +5,7 @@
     <p:sldMasterId id="2147483667" r:id="rId1"/>
   </p:sldMasterIdLst>
   <p:notesMasterIdLst>
-    <p:notesMasterId r:id="rId16"/>
+    <p:notesMasterId r:id="rId17"/>
   </p:notesMasterIdLst>
   <p:sldIdLst>
     <p:sldId id="271" r:id="rId2"/>
@@ -17,19 +17,20 @@
     <p:sldId id="308" r:id="rId8"/>
     <p:sldId id="314" r:id="rId9"/>
     <p:sldId id="302" r:id="rId10"/>
-    <p:sldId id="311" r:id="rId11"/>
-    <p:sldId id="310" r:id="rId12"/>
+    <p:sldId id="310" r:id="rId11"/>
+    <p:sldId id="315" r:id="rId12"/>
     <p:sldId id="303" r:id="rId13"/>
-    <p:sldId id="278" r:id="rId14"/>
-    <p:sldId id="296" r:id="rId15"/>
+    <p:sldId id="317" r:id="rId14"/>
+    <p:sldId id="278" r:id="rId15"/>
+    <p:sldId id="296" r:id="rId16"/>
   </p:sldIdLst>
   <p:sldSz cx="9144000" cy="5143500" type="screen16x9"/>
   <p:notesSz cx="6858000" cy="9144000"/>
   <p:embeddedFontLst>
     <p:embeddedFont>
       <p:font typeface="Assistant" pitchFamily="2" charset="-79"/>
-      <p:regular r:id="rId17"/>
-      <p:bold r:id="rId18"/>
+      <p:regular r:id="rId18"/>
+      <p:bold r:id="rId19"/>
     </p:embeddedFont>
   </p:embeddedFontLst>
   <p:defaultTextStyle>
@@ -344,6 +345,13 @@
             <a:tailEnd type="none" w="sm" len="sm"/>
           </a:ln>
         </p:spPr>
+        <p:txBody>
+          <a:bodyPr/>
+          <a:lstStyle/>
+          <a:p>
+            <a:endParaRPr lang="en-US"/>
+          </a:p>
+        </p:txBody>
       </p:sp>
       <p:sp>
         <p:nvSpPr>
@@ -770,6 +778,13 @@
             </a:pathLst>
           </a:custGeom>
         </p:spPr>
+        <p:txBody>
+          <a:bodyPr/>
+          <a:lstStyle/>
+          <a:p>
+            <a:endParaRPr lang="en-US"/>
+          </a:p>
+        </p:txBody>
       </p:sp>
       <p:sp>
         <p:nvSpPr>
@@ -886,6 +901,13 @@
             </a:pathLst>
           </a:custGeom>
         </p:spPr>
+        <p:txBody>
+          <a:bodyPr/>
+          <a:lstStyle/>
+          <a:p>
+            <a:endParaRPr lang="en-US"/>
+          </a:p>
+        </p:txBody>
       </p:sp>
       <p:sp>
         <p:nvSpPr>
@@ -1001,6 +1023,13 @@
             </a:pathLst>
           </a:custGeom>
         </p:spPr>
+        <p:txBody>
+          <a:bodyPr/>
+          <a:lstStyle/>
+          <a:p>
+            <a:endParaRPr lang="en-US"/>
+          </a:p>
+        </p:txBody>
       </p:sp>
       <p:sp>
         <p:nvSpPr>
@@ -1105,6 +1134,13 @@
             </a:pathLst>
           </a:custGeom>
         </p:spPr>
+        <p:txBody>
+          <a:bodyPr/>
+          <a:lstStyle/>
+          <a:p>
+            <a:endParaRPr lang="en-US"/>
+          </a:p>
+        </p:txBody>
       </p:sp>
       <p:sp>
         <p:nvSpPr>
@@ -1221,6 +1257,13 @@
             </a:pathLst>
           </a:custGeom>
         </p:spPr>
+        <p:txBody>
+          <a:bodyPr/>
+          <a:lstStyle/>
+          <a:p>
+            <a:endParaRPr lang="en-US"/>
+          </a:p>
+        </p:txBody>
       </p:sp>
       <p:sp>
         <p:nvSpPr>
@@ -1336,6 +1379,13 @@
             </a:pathLst>
           </a:custGeom>
         </p:spPr>
+        <p:txBody>
+          <a:bodyPr/>
+          <a:lstStyle/>
+          <a:p>
+            <a:endParaRPr lang="en-US"/>
+          </a:p>
+        </p:txBody>
       </p:sp>
       <p:sp>
         <p:nvSpPr>
@@ -1452,6 +1502,13 @@
             </a:pathLst>
           </a:custGeom>
         </p:spPr>
+        <p:txBody>
+          <a:bodyPr/>
+          <a:lstStyle/>
+          <a:p>
+            <a:endParaRPr lang="en-US"/>
+          </a:p>
+        </p:txBody>
       </p:sp>
       <p:sp>
         <p:nvSpPr>
@@ -1579,6 +1636,13 @@
             </a:pathLst>
           </a:custGeom>
         </p:spPr>
+        <p:txBody>
+          <a:bodyPr/>
+          <a:lstStyle/>
+          <a:p>
+            <a:endParaRPr lang="en-US"/>
+          </a:p>
+        </p:txBody>
       </p:sp>
       <p:sp>
         <p:nvSpPr>
@@ -1706,6 +1770,13 @@
             </a:pathLst>
           </a:custGeom>
         </p:spPr>
+        <p:txBody>
+          <a:bodyPr/>
+          <a:lstStyle/>
+          <a:p>
+            <a:endParaRPr lang="en-US"/>
+          </a:p>
+        </p:txBody>
       </p:sp>
       <p:sp>
         <p:nvSpPr>
@@ -1833,6 +1904,13 @@
             </a:pathLst>
           </a:custGeom>
         </p:spPr>
+        <p:txBody>
+          <a:bodyPr/>
+          <a:lstStyle/>
+          <a:p>
+            <a:endParaRPr lang="en-US"/>
+          </a:p>
+        </p:txBody>
       </p:sp>
       <p:sp>
         <p:nvSpPr>
@@ -1892,133 +1970,6 @@
 </file>
 
 <file path=ppt/notesSlides/notesSlide8.xml><?xml version="1.0" encoding="utf-8"?>
-<p:notes xmlns:a="http://schemas.openxmlformats.org/drawingml/2006/main" xmlns:r="http://schemas.openxmlformats.org/officeDocument/2006/relationships" xmlns:p="http://schemas.openxmlformats.org/presentationml/2006/main" showMasterSp="0" showMasterPhAnim="0">
-  <p:cSld>
-    <p:spTree>
-      <p:nvGrpSpPr>
-        <p:cNvPr id="1" name="Shape 441">
-          <a:extLst>
-            <a:ext uri="{FF2B5EF4-FFF2-40B4-BE49-F238E27FC236}">
-              <a16:creationId xmlns:a16="http://schemas.microsoft.com/office/drawing/2014/main" id="{1DC65EF7-451A-79D6-1361-D903A016D4A0}"/>
-            </a:ext>
-          </a:extLst>
-        </p:cNvPr>
-        <p:cNvGrpSpPr/>
-        <p:nvPr/>
-      </p:nvGrpSpPr>
-      <p:grpSpPr>
-        <a:xfrm>
-          <a:off x="0" y="0"/>
-          <a:ext cx="0" cy="0"/>
-          <a:chOff x="0" y="0"/>
-          <a:chExt cx="0" cy="0"/>
-        </a:xfrm>
-      </p:grpSpPr>
-      <p:sp>
-        <p:nvSpPr>
-          <p:cNvPr id="442" name="Google Shape;442;gaf83f1124d_0_42:notes">
-            <a:extLst>
-              <a:ext uri="{FF2B5EF4-FFF2-40B4-BE49-F238E27FC236}">
-                <a16:creationId xmlns:a16="http://schemas.microsoft.com/office/drawing/2014/main" id="{3FB6211C-FBF3-2CC3-1AF4-45BE9EE1491C}"/>
-              </a:ext>
-            </a:extLst>
-          </p:cNvPr>
-          <p:cNvSpPr>
-            <a:spLocks noGrp="1" noRot="1" noChangeAspect="1"/>
-          </p:cNvSpPr>
-          <p:nvPr>
-            <p:ph type="sldImg" idx="2"/>
-          </p:nvPr>
-        </p:nvSpPr>
-        <p:spPr>
-          <a:xfrm>
-            <a:off x="381000" y="685800"/>
-            <a:ext cx="6096000" cy="3429000"/>
-          </a:xfrm>
-          <a:custGeom>
-            <a:avLst/>
-            <a:gdLst/>
-            <a:ahLst/>
-            <a:cxnLst/>
-            <a:rect l="l" t="t" r="r" b="b"/>
-            <a:pathLst>
-              <a:path w="120000" h="120000" extrusionOk="0">
-                <a:moveTo>
-                  <a:pt x="0" y="0"/>
-                </a:moveTo>
-                <a:lnTo>
-                  <a:pt x="120000" y="0"/>
-                </a:lnTo>
-                <a:lnTo>
-                  <a:pt x="120000" y="120000"/>
-                </a:lnTo>
-                <a:lnTo>
-                  <a:pt x="0" y="120000"/>
-                </a:lnTo>
-                <a:close/>
-              </a:path>
-            </a:pathLst>
-          </a:custGeom>
-        </p:spPr>
-      </p:sp>
-      <p:sp>
-        <p:nvSpPr>
-          <p:cNvPr id="443" name="Google Shape;443;gaf83f1124d_0_42:notes">
-            <a:extLst>
-              <a:ext uri="{FF2B5EF4-FFF2-40B4-BE49-F238E27FC236}">
-                <a16:creationId xmlns:a16="http://schemas.microsoft.com/office/drawing/2014/main" id="{6B3901D1-C1DB-38C3-DE86-B0E148394117}"/>
-              </a:ext>
-            </a:extLst>
-          </p:cNvPr>
-          <p:cNvSpPr txBox="1">
-            <a:spLocks noGrp="1"/>
-          </p:cNvSpPr>
-          <p:nvPr>
-            <p:ph type="body" idx="1"/>
-          </p:nvPr>
-        </p:nvSpPr>
-        <p:spPr>
-          <a:xfrm>
-            <a:off x="685800" y="4343400"/>
-            <a:ext cx="5486400" cy="4114800"/>
-          </a:xfrm>
-          <a:prstGeom prst="rect">
-            <a:avLst/>
-          </a:prstGeom>
-        </p:spPr>
-        <p:txBody>
-          <a:bodyPr spcFirstLastPara="1" wrap="square" lIns="91425" tIns="91425" rIns="91425" bIns="91425" anchor="t" anchorCtr="0">
-            <a:noAutofit/>
-          </a:bodyPr>
-          <a:lstStyle/>
-          <a:p>
-            <a:pPr marL="0" lvl="0" indent="0" algn="l" rtl="0">
-              <a:spcBef>
-                <a:spcPts val="0"/>
-              </a:spcBef>
-              <a:spcAft>
-                <a:spcPts val="0"/>
-              </a:spcAft>
-              <a:buNone/>
-            </a:pPr>
-            <a:endParaRPr/>
-          </a:p>
-        </p:txBody>
-      </p:sp>
-    </p:spTree>
-    <p:extLst>
-      <p:ext uri="{BB962C8B-B14F-4D97-AF65-F5344CB8AC3E}">
-        <p14:creationId xmlns:p14="http://schemas.microsoft.com/office/powerpoint/2010/main" val="3504596559"/>
-      </p:ext>
-    </p:extLst>
-  </p:cSld>
-  <p:clrMapOvr>
-    <a:masterClrMapping/>
-  </p:clrMapOvr>
-</p:notes>
-</file>
-
-<file path=ppt/notesSlides/notesSlide9.xml><?xml version="1.0" encoding="utf-8"?>
 <p:notes xmlns:a="http://schemas.openxmlformats.org/drawingml/2006/main" xmlns:r="http://schemas.openxmlformats.org/officeDocument/2006/relationships" xmlns:p="http://schemas.openxmlformats.org/presentationml/2006/main" showMasterSp="0" showMasterPhAnim="0">
   <p:cSld>
     <p:spTree>
@@ -2087,6 +2038,13 @@
             </a:pathLst>
           </a:custGeom>
         </p:spPr>
+        <p:txBody>
+          <a:bodyPr/>
+          <a:lstStyle/>
+          <a:p>
+            <a:endParaRPr lang="en-US"/>
+          </a:p>
+        </p:txBody>
       </p:sp>
       <p:sp>
         <p:nvSpPr>
@@ -2136,6 +2094,79 @@
     <p:extLst>
       <p:ext uri="{BB962C8B-B14F-4D97-AF65-F5344CB8AC3E}">
         <p14:creationId xmlns:p14="http://schemas.microsoft.com/office/powerpoint/2010/main" val="3692360795"/>
+      </p:ext>
+    </p:extLst>
+  </p:cSld>
+  <p:clrMapOvr>
+    <a:masterClrMapping/>
+  </p:clrMapOvr>
+</p:notes>
+</file>
+
+<file path=ppt/notesSlides/notesSlide9.xml><?xml version="1.0" encoding="utf-8"?>
+<p:notes xmlns:a="http://schemas.openxmlformats.org/drawingml/2006/main" xmlns:r="http://schemas.openxmlformats.org/officeDocument/2006/relationships" xmlns:p="http://schemas.openxmlformats.org/presentationml/2006/main">
+  <p:cSld>
+    <p:spTree>
+      <p:nvGrpSpPr>
+        <p:cNvPr id="1" name=""/>
+        <p:cNvGrpSpPr/>
+        <p:nvPr/>
+      </p:nvGrpSpPr>
+      <p:grpSpPr>
+        <a:xfrm>
+          <a:off x="0" y="0"/>
+          <a:ext cx="0" cy="0"/>
+          <a:chOff x="0" y="0"/>
+          <a:chExt cx="0" cy="0"/>
+        </a:xfrm>
+      </p:grpSpPr>
+      <p:sp>
+        <p:nvSpPr>
+          <p:cNvPr id="2" name="Slide Image Placeholder 1"/>
+          <p:cNvSpPr>
+            <a:spLocks noGrp="1" noRot="1" noChangeAspect="1"/>
+          </p:cNvSpPr>
+          <p:nvPr>
+            <p:ph type="sldImg"/>
+          </p:nvPr>
+        </p:nvSpPr>
+        <p:spPr>
+          <a:xfrm>
+            <a:off x="381000" y="685800"/>
+            <a:ext cx="6096000" cy="3429000"/>
+          </a:xfrm>
+        </p:spPr>
+        <p:txBody>
+          <a:bodyPr/>
+          <a:lstStyle/>
+          <a:p>
+            <a:endParaRPr lang="en-US"/>
+          </a:p>
+        </p:txBody>
+      </p:sp>
+      <p:sp>
+        <p:nvSpPr>
+          <p:cNvPr id="3" name="Notes Placeholder 2"/>
+          <p:cNvSpPr>
+            <a:spLocks noGrp="1"/>
+          </p:cNvSpPr>
+          <p:nvPr>
+            <p:ph type="body" idx="1"/>
+          </p:nvPr>
+        </p:nvSpPr>
+        <p:spPr/>
+        <p:txBody>
+          <a:bodyPr/>
+          <a:lstStyle/>
+          <a:p>
+            <a:endParaRPr lang="en-US" dirty="0"/>
+          </a:p>
+        </p:txBody>
+      </p:sp>
+    </p:spTree>
+    <p:extLst>
+      <p:ext uri="{BB962C8B-B14F-4D97-AF65-F5344CB8AC3E}">
+        <p14:creationId xmlns:p14="http://schemas.microsoft.com/office/powerpoint/2010/main" val="438929749"/>
       </p:ext>
     </p:extLst>
   </p:cSld>
@@ -3000,6 +3031,13 @@
             <a:noFill/>
           </a:ln>
         </p:spPr>
+        <p:txBody>
+          <a:bodyPr/>
+          <a:lstStyle/>
+          <a:p>
+            <a:endParaRPr lang="en-US"/>
+          </a:p>
+        </p:txBody>
       </p:sp>
       <p:sp>
         <p:nvSpPr>
@@ -3102,6 +3140,13 @@
             <a:noFill/>
           </a:ln>
         </p:spPr>
+        <p:txBody>
+          <a:bodyPr/>
+          <a:lstStyle/>
+          <a:p>
+            <a:endParaRPr lang="en-US"/>
+          </a:p>
+        </p:txBody>
       </p:sp>
     </p:spTree>
   </p:cSld>
@@ -5611,376 +5656,6 @@
   <p:cSld>
     <p:spTree>
       <p:nvGrpSpPr>
-        <p:cNvPr id="1" name="Shape 444">
-          <a:extLst>
-            <a:ext uri="{FF2B5EF4-FFF2-40B4-BE49-F238E27FC236}">
-              <a16:creationId xmlns:a16="http://schemas.microsoft.com/office/drawing/2014/main" id="{A7C46DA7-78FD-6408-34B2-0DF18A62D8ED}"/>
-            </a:ext>
-          </a:extLst>
-        </p:cNvPr>
-        <p:cNvGrpSpPr/>
-        <p:nvPr/>
-      </p:nvGrpSpPr>
-      <p:grpSpPr>
-        <a:xfrm>
-          <a:off x="0" y="0"/>
-          <a:ext cx="0" cy="0"/>
-          <a:chOff x="0" y="0"/>
-          <a:chExt cx="0" cy="0"/>
-        </a:xfrm>
-      </p:grpSpPr>
-      <p:sp>
-        <p:nvSpPr>
-          <p:cNvPr id="3" name="Title 2">
-            <a:extLst>
-              <a:ext uri="{FF2B5EF4-FFF2-40B4-BE49-F238E27FC236}">
-                <a16:creationId xmlns:a16="http://schemas.microsoft.com/office/drawing/2014/main" id="{6E99D350-BB3B-3CA5-D285-B8F1977E51F4}"/>
-              </a:ext>
-            </a:extLst>
-          </p:cNvPr>
-          <p:cNvSpPr>
-            <a:spLocks noGrp="1"/>
-          </p:cNvSpPr>
-          <p:nvPr>
-            <p:ph type="title"/>
-          </p:nvPr>
-        </p:nvSpPr>
-        <p:spPr/>
-        <p:txBody>
-          <a:bodyPr>
-            <a:noAutofit/>
-          </a:bodyPr>
-          <a:lstStyle/>
-          <a:p>
-            <a:r>
-              <a:rPr lang="en-US" sz="2000" dirty="0"/>
-              <a:t>Confusion Matrices of Top 3 Models</a:t>
-            </a:r>
-          </a:p>
-        </p:txBody>
-      </p:sp>
-      <p:sp>
-        <p:nvSpPr>
-          <p:cNvPr id="4" name="TextBox 3">
-            <a:extLst>
-              <a:ext uri="{FF2B5EF4-FFF2-40B4-BE49-F238E27FC236}">
-                <a16:creationId xmlns:a16="http://schemas.microsoft.com/office/drawing/2014/main" id="{77635EC7-2E34-396A-C103-BCF852AA9DD1}"/>
-              </a:ext>
-            </a:extLst>
-          </p:cNvPr>
-          <p:cNvSpPr txBox="1"/>
-          <p:nvPr/>
-        </p:nvSpPr>
-        <p:spPr>
-          <a:xfrm>
-            <a:off x="631371" y="1143001"/>
-            <a:ext cx="6226629" cy="1815882"/>
-          </a:xfrm>
-          <a:prstGeom prst="rect">
-            <a:avLst/>
-          </a:prstGeom>
-          <a:noFill/>
-        </p:spPr>
-        <p:txBody>
-          <a:bodyPr wrap="square">
-            <a:spAutoFit/>
-          </a:bodyPr>
-          <a:lstStyle/>
-          <a:p>
-            <a:r>
-              <a:rPr lang="en-US" dirty="0" err="1"/>
-              <a:t>XGBoost</a:t>
-            </a:r>
-            <a:r>
-              <a:rPr lang="en-US" dirty="0"/>
-              <a:t> Optimized makes the most correct predictions (5,757)</a:t>
-            </a:r>
-          </a:p>
-          <a:p>
-            <a:endParaRPr lang="en-US" dirty="0"/>
-          </a:p>
-          <a:p>
-            <a:r>
-              <a:rPr lang="en-US" dirty="0"/>
-              <a:t>Gradient Boosting misses the fewest churners (817)</a:t>
-            </a:r>
-          </a:p>
-          <a:p>
-            <a:endParaRPr lang="en-US" dirty="0"/>
-          </a:p>
-          <a:p>
-            <a:r>
-              <a:rPr lang="en-US" dirty="0"/>
-              <a:t>All models struggle with False Positives (~2,400-2,500)</a:t>
-            </a:r>
-          </a:p>
-          <a:p>
-            <a:endParaRPr lang="en-US" dirty="0"/>
-          </a:p>
-          <a:p>
-            <a:r>
-              <a:rPr lang="en-US" dirty="0"/>
-              <a:t>False Negatives are most costly, because the business loses customers that could have been saved.</a:t>
-            </a:r>
-          </a:p>
-        </p:txBody>
-      </p:sp>
-      <p:grpSp>
-        <p:nvGrpSpPr>
-          <p:cNvPr id="2" name="Google Shape;451;p42">
-            <a:extLst>
-              <a:ext uri="{FF2B5EF4-FFF2-40B4-BE49-F238E27FC236}">
-                <a16:creationId xmlns:a16="http://schemas.microsoft.com/office/drawing/2014/main" id="{D176D2F1-EEA0-6034-89BF-F7B7CC757C8D}"/>
-              </a:ext>
-            </a:extLst>
-          </p:cNvPr>
-          <p:cNvGrpSpPr/>
-          <p:nvPr/>
-        </p:nvGrpSpPr>
-        <p:grpSpPr>
-          <a:xfrm rot="10800000">
-            <a:off x="203785" y="4564699"/>
-            <a:ext cx="427586" cy="471802"/>
-            <a:chOff x="4185575" y="3320360"/>
-            <a:chExt cx="1104178" cy="1104176"/>
-          </a:xfrm>
-        </p:grpSpPr>
-        <p:sp>
-          <p:nvSpPr>
-            <p:cNvPr id="5" name="Google Shape;452;p42">
-              <a:extLst>
-                <a:ext uri="{FF2B5EF4-FFF2-40B4-BE49-F238E27FC236}">
-                  <a16:creationId xmlns:a16="http://schemas.microsoft.com/office/drawing/2014/main" id="{5AD37647-041B-FB21-C2D2-EC24F7EC9FCD}"/>
-                </a:ext>
-              </a:extLst>
-            </p:cNvPr>
-            <p:cNvSpPr/>
-            <p:nvPr/>
-          </p:nvSpPr>
-          <p:spPr>
-            <a:xfrm>
-              <a:off x="4185575" y="3421936"/>
-              <a:ext cx="1002600" cy="1002600"/>
-            </a:xfrm>
-            <a:prstGeom prst="ellipse">
-              <a:avLst/>
-            </a:prstGeom>
-            <a:solidFill>
-              <a:schemeClr val="accent1"/>
-            </a:solidFill>
-            <a:ln>
-              <a:noFill/>
-            </a:ln>
-          </p:spPr>
-          <p:txBody>
-            <a:bodyPr spcFirstLastPara="1" wrap="square" lIns="91425" tIns="91425" rIns="91425" bIns="91425" anchor="ctr" anchorCtr="0">
-              <a:noAutofit/>
-            </a:bodyPr>
-            <a:lstStyle/>
-            <a:p>
-              <a:pPr marL="0" lvl="0" indent="0" algn="l" rtl="0">
-                <a:spcBef>
-                  <a:spcPts val="0"/>
-                </a:spcBef>
-                <a:spcAft>
-                  <a:spcPts val="0"/>
-                </a:spcAft>
-                <a:buNone/>
-              </a:pPr>
-              <a:endParaRPr/>
-            </a:p>
-          </p:txBody>
-        </p:sp>
-        <p:sp>
-          <p:nvSpPr>
-            <p:cNvPr id="6" name="Google Shape;453;p42">
-              <a:extLst>
-                <a:ext uri="{FF2B5EF4-FFF2-40B4-BE49-F238E27FC236}">
-                  <a16:creationId xmlns:a16="http://schemas.microsoft.com/office/drawing/2014/main" id="{FBE4F53B-76A7-FB67-268F-40EAB1BF5A25}"/>
-                </a:ext>
-              </a:extLst>
-            </p:cNvPr>
-            <p:cNvSpPr/>
-            <p:nvPr/>
-          </p:nvSpPr>
-          <p:spPr>
-            <a:xfrm>
-              <a:off x="4287153" y="3320360"/>
-              <a:ext cx="1002600" cy="1002600"/>
-            </a:xfrm>
-            <a:prstGeom prst="ellipse">
-              <a:avLst/>
-            </a:prstGeom>
-            <a:noFill/>
-            <a:ln w="19050" cap="flat" cmpd="sng">
-              <a:solidFill>
-                <a:schemeClr val="dk1"/>
-              </a:solidFill>
-              <a:prstDash val="solid"/>
-              <a:round/>
-              <a:headEnd type="none" w="sm" len="sm"/>
-              <a:tailEnd type="none" w="sm" len="sm"/>
-            </a:ln>
-          </p:spPr>
-          <p:txBody>
-            <a:bodyPr spcFirstLastPara="1" wrap="square" lIns="91425" tIns="91425" rIns="91425" bIns="91425" anchor="ctr" anchorCtr="0">
-              <a:noAutofit/>
-            </a:bodyPr>
-            <a:lstStyle/>
-            <a:p>
-              <a:pPr marL="0" lvl="0" indent="0" algn="l" rtl="0">
-                <a:spcBef>
-                  <a:spcPts val="0"/>
-                </a:spcBef>
-                <a:spcAft>
-                  <a:spcPts val="0"/>
-                </a:spcAft>
-                <a:buNone/>
-              </a:pPr>
-              <a:endParaRPr/>
-            </a:p>
-          </p:txBody>
-        </p:sp>
-      </p:grpSp>
-      <p:grpSp>
-        <p:nvGrpSpPr>
-          <p:cNvPr id="7" name="Google Shape;438;p41">
-            <a:extLst>
-              <a:ext uri="{FF2B5EF4-FFF2-40B4-BE49-F238E27FC236}">
-                <a16:creationId xmlns:a16="http://schemas.microsoft.com/office/drawing/2014/main" id="{EBAE6D97-CB67-AC58-1030-54045E9A926A}"/>
-              </a:ext>
-            </a:extLst>
-          </p:cNvPr>
-          <p:cNvGrpSpPr/>
-          <p:nvPr/>
-        </p:nvGrpSpPr>
-        <p:grpSpPr>
-          <a:xfrm rot="8100353">
-            <a:off x="8588324" y="4388227"/>
-            <a:ext cx="474828" cy="511970"/>
-            <a:chOff x="673800" y="3053202"/>
-            <a:chExt cx="948075" cy="873823"/>
-          </a:xfrm>
-        </p:grpSpPr>
-        <p:sp>
-          <p:nvSpPr>
-            <p:cNvPr id="8" name="Google Shape;439;p41">
-              <a:extLst>
-                <a:ext uri="{FF2B5EF4-FFF2-40B4-BE49-F238E27FC236}">
-                  <a16:creationId xmlns:a16="http://schemas.microsoft.com/office/drawing/2014/main" id="{5B1ED891-7350-CC21-C33E-0C61425EF92A}"/>
-                </a:ext>
-              </a:extLst>
-            </p:cNvPr>
-            <p:cNvSpPr/>
-            <p:nvPr/>
-          </p:nvSpPr>
-          <p:spPr>
-            <a:xfrm>
-              <a:off x="706575" y="3053202"/>
-              <a:ext cx="915300" cy="791701"/>
-            </a:xfrm>
-            <a:prstGeom prst="triangle">
-              <a:avLst>
-                <a:gd name="adj" fmla="val 50000"/>
-              </a:avLst>
-            </a:prstGeom>
-            <a:solidFill>
-              <a:schemeClr val="accent1"/>
-            </a:solidFill>
-            <a:ln>
-              <a:noFill/>
-            </a:ln>
-          </p:spPr>
-          <p:txBody>
-            <a:bodyPr spcFirstLastPara="1" wrap="square" lIns="91425" tIns="91425" rIns="91425" bIns="91425" anchor="ctr" anchorCtr="0">
-              <a:noAutofit/>
-            </a:bodyPr>
-            <a:lstStyle/>
-            <a:p>
-              <a:pPr marL="0" lvl="0" indent="0" algn="l" rtl="0">
-                <a:spcBef>
-                  <a:spcPts val="0"/>
-                </a:spcBef>
-                <a:spcAft>
-                  <a:spcPts val="0"/>
-                </a:spcAft>
-                <a:buNone/>
-              </a:pPr>
-              <a:endParaRPr dirty="0"/>
-            </a:p>
-          </p:txBody>
-        </p:sp>
-        <p:sp>
-          <p:nvSpPr>
-            <p:cNvPr id="9" name="Google Shape;440;p41">
-              <a:extLst>
-                <a:ext uri="{FF2B5EF4-FFF2-40B4-BE49-F238E27FC236}">
-                  <a16:creationId xmlns:a16="http://schemas.microsoft.com/office/drawing/2014/main" id="{6846E118-5BCE-C352-E1ED-E834B165A878}"/>
-                </a:ext>
-              </a:extLst>
-            </p:cNvPr>
-            <p:cNvSpPr/>
-            <p:nvPr/>
-          </p:nvSpPr>
-          <p:spPr>
-            <a:xfrm>
-              <a:off x="673800" y="3135325"/>
-              <a:ext cx="915300" cy="791700"/>
-            </a:xfrm>
-            <a:prstGeom prst="triangle">
-              <a:avLst>
-                <a:gd name="adj" fmla="val 50000"/>
-              </a:avLst>
-            </a:prstGeom>
-            <a:noFill/>
-            <a:ln w="19050" cap="flat" cmpd="sng">
-              <a:solidFill>
-                <a:schemeClr val="dk1"/>
-              </a:solidFill>
-              <a:prstDash val="solid"/>
-              <a:round/>
-              <a:headEnd type="none" w="sm" len="sm"/>
-              <a:tailEnd type="none" w="sm" len="sm"/>
-            </a:ln>
-          </p:spPr>
-          <p:txBody>
-            <a:bodyPr spcFirstLastPara="1" wrap="square" lIns="91425" tIns="91425" rIns="91425" bIns="91425" anchor="ctr" anchorCtr="0">
-              <a:noAutofit/>
-            </a:bodyPr>
-            <a:lstStyle/>
-            <a:p>
-              <a:pPr marL="0" lvl="0" indent="0" algn="l" rtl="0">
-                <a:spcBef>
-                  <a:spcPts val="0"/>
-                </a:spcBef>
-                <a:spcAft>
-                  <a:spcPts val="0"/>
-                </a:spcAft>
-                <a:buNone/>
-              </a:pPr>
-              <a:endParaRPr/>
-            </a:p>
-          </p:txBody>
-        </p:sp>
-      </p:grpSp>
-    </p:spTree>
-    <p:extLst>
-      <p:ext uri="{BB962C8B-B14F-4D97-AF65-F5344CB8AC3E}">
-        <p14:creationId xmlns:p14="http://schemas.microsoft.com/office/powerpoint/2010/main" val="2026826386"/>
-      </p:ext>
-    </p:extLst>
-  </p:cSld>
-  <p:clrMapOvr>
-    <a:masterClrMapping/>
-  </p:clrMapOvr>
-</p:sld>
-</file>
-
-<file path=ppt/slides/slide11.xml><?xml version="1.0" encoding="utf-8"?>
-<p:sld xmlns:a="http://schemas.openxmlformats.org/drawingml/2006/main" xmlns:r="http://schemas.openxmlformats.org/officeDocument/2006/relationships" xmlns:p="http://schemas.openxmlformats.org/presentationml/2006/main">
-  <p:cSld>
-    <p:spTree>
-      <p:nvGrpSpPr>
         <p:cNvPr id="1" name="Shape 431">
           <a:extLst>
             <a:ext uri="{FF2B5EF4-FFF2-40B4-BE49-F238E27FC236}">
@@ -6237,6 +5912,155 @@
 </p:sld>
 </file>
 
+<file path=ppt/slides/slide11.xml><?xml version="1.0" encoding="utf-8"?>
+<p:sld xmlns:a="http://schemas.openxmlformats.org/drawingml/2006/main" xmlns:r="http://schemas.openxmlformats.org/officeDocument/2006/relationships" xmlns:p="http://schemas.openxmlformats.org/presentationml/2006/main">
+  <p:cSld>
+    <p:spTree>
+      <p:nvGrpSpPr>
+        <p:cNvPr id="1" name=""/>
+        <p:cNvGrpSpPr/>
+        <p:nvPr/>
+      </p:nvGrpSpPr>
+      <p:grpSpPr>
+        <a:xfrm>
+          <a:off x="0" y="0"/>
+          <a:ext cx="0" cy="0"/>
+          <a:chOff x="0" y="0"/>
+          <a:chExt cx="0" cy="0"/>
+        </a:xfrm>
+      </p:grpSpPr>
+      <p:sp>
+        <p:nvSpPr>
+          <p:cNvPr id="4" name="Slide Number Placeholder 3">
+            <a:extLst>
+              <a:ext uri="{FF2B5EF4-FFF2-40B4-BE49-F238E27FC236}">
+                <a16:creationId xmlns:a16="http://schemas.microsoft.com/office/drawing/2014/main" id="{9DA09F7C-6039-631A-D55F-C0ECFB800174}"/>
+              </a:ext>
+            </a:extLst>
+          </p:cNvPr>
+          <p:cNvSpPr>
+            <a:spLocks noGrp="1"/>
+          </p:cNvSpPr>
+          <p:nvPr>
+            <p:ph type="sldNum" idx="12"/>
+          </p:nvPr>
+        </p:nvSpPr>
+        <p:spPr/>
+        <p:txBody>
+          <a:bodyPr>
+            <a:normAutofit fontScale="92500" lnSpcReduction="20000"/>
+          </a:bodyPr>
+          <a:lstStyle/>
+          <a:p>
+            <a:pPr marL="0" lvl="0" indent="0" algn="r" rtl="0">
+              <a:spcBef>
+                <a:spcPts val="0"/>
+              </a:spcBef>
+              <a:spcAft>
+                <a:spcPts val="0"/>
+              </a:spcAft>
+              <a:buNone/>
+            </a:pPr>
+            <a:fld id="{00000000-1234-1234-1234-123412341234}" type="slidenum">
+              <a:rPr lang="en" smtClean="0"/>
+              <a:t>11</a:t>
+            </a:fld>
+            <a:endParaRPr lang="en"/>
+          </a:p>
+        </p:txBody>
+      </p:sp>
+      <p:pic>
+        <p:nvPicPr>
+          <p:cNvPr id="7" name="Picture 6">
+            <a:extLst>
+              <a:ext uri="{FF2B5EF4-FFF2-40B4-BE49-F238E27FC236}">
+                <a16:creationId xmlns:a16="http://schemas.microsoft.com/office/drawing/2014/main" id="{A777F260-FD4E-11E8-AEA2-A38EFAAB98F7}"/>
+              </a:ext>
+            </a:extLst>
+          </p:cNvPr>
+          <p:cNvPicPr>
+            <a:picLocks noChangeAspect="1"/>
+          </p:cNvPicPr>
+          <p:nvPr/>
+        </p:nvPicPr>
+        <p:blipFill>
+          <a:blip r:embed="rId3"/>
+          <a:stretch>
+            <a:fillRect/>
+          </a:stretch>
+        </p:blipFill>
+        <p:spPr>
+          <a:xfrm>
+            <a:off x="2164465" y="887471"/>
+            <a:ext cx="3819647" cy="4149401"/>
+          </a:xfrm>
+          <a:prstGeom prst="rect">
+            <a:avLst/>
+          </a:prstGeom>
+        </p:spPr>
+      </p:pic>
+      <p:sp>
+        <p:nvSpPr>
+          <p:cNvPr id="10" name="TextBox 9">
+            <a:extLst>
+              <a:ext uri="{FF2B5EF4-FFF2-40B4-BE49-F238E27FC236}">
+                <a16:creationId xmlns:a16="http://schemas.microsoft.com/office/drawing/2014/main" id="{BFB26DE6-9779-0DC5-D87D-4857CC273440}"/>
+              </a:ext>
+            </a:extLst>
+          </p:cNvPr>
+          <p:cNvSpPr txBox="1"/>
+          <p:nvPr/>
+        </p:nvSpPr>
+        <p:spPr>
+          <a:xfrm>
+            <a:off x="1504709" y="231494"/>
+            <a:ext cx="5880136" cy="400110"/>
+          </a:xfrm>
+          <a:prstGeom prst="rect">
+            <a:avLst/>
+          </a:prstGeom>
+          <a:noFill/>
+        </p:spPr>
+        <p:txBody>
+          <a:bodyPr wrap="none" rtlCol="0">
+            <a:spAutoFit/>
+          </a:bodyPr>
+          <a:lstStyle/>
+          <a:p>
+            <a:r>
+              <a:rPr lang="en-US" sz="2000" dirty="0">
+                <a:latin typeface=""/>
+              </a:rPr>
+              <a:t>SHAP Feature Importance for </a:t>
+            </a:r>
+            <a:r>
+              <a:rPr lang="en-US" sz="2000" dirty="0" err="1">
+                <a:latin typeface=""/>
+              </a:rPr>
+              <a:t>XGBoost</a:t>
+            </a:r>
+            <a:r>
+              <a:rPr lang="en-US" sz="2000" dirty="0">
+                <a:latin typeface=""/>
+              </a:rPr>
+              <a:t> Optimized</a:t>
+            </a:r>
+          </a:p>
+        </p:txBody>
+      </p:sp>
+    </p:spTree>
+    <p:extLst>
+      <p:ext uri="{BB962C8B-B14F-4D97-AF65-F5344CB8AC3E}">
+        <p14:creationId xmlns:p14="http://schemas.microsoft.com/office/powerpoint/2010/main" val="635495103"/>
+      </p:ext>
+    </p:extLst>
+  </p:cSld>
+  <p:clrMapOvr>
+    <a:masterClrMapping/>
+  </p:clrMapOvr>
+</p:sld>
+</file>
+
 <file path=ppt/slides/slide12.xml><?xml version="1.0" encoding="utf-8"?>
 <p:sld xmlns:a="http://schemas.openxmlformats.org/drawingml/2006/main" xmlns:r="http://schemas.openxmlformats.org/officeDocument/2006/relationships" xmlns:p="http://schemas.openxmlformats.org/presentationml/2006/main">
   <p:cSld>
@@ -6287,12 +6111,12 @@
         </p:spPr>
         <p:txBody>
           <a:bodyPr spcFirstLastPara="1" wrap="square" lIns="91425" tIns="91425" rIns="91425" bIns="91425" anchor="ctr" anchorCtr="0">
-            <a:normAutofit fontScale="90000"/>
+            <a:normAutofit/>
           </a:bodyPr>
           <a:lstStyle/>
           <a:p>
             <a:r>
-              <a:rPr lang="en-US" dirty="0"/>
+              <a:rPr lang="en-US" sz="2000" dirty="0"/>
               <a:t>Key Takeaways</a:t>
             </a:r>
           </a:p>
@@ -6329,23 +6153,18 @@
           </a:bodyPr>
           <a:lstStyle/>
           <a:p>
-            <a:pPr marL="114300" indent="0">
-              <a:spcBef>
-                <a:spcPts val="1000"/>
-              </a:spcBef>
-              <a:buNone/>
-            </a:pPr>
-            <a:endParaRPr lang="en-US" dirty="0"/>
-          </a:p>
-          <a:p>
             <a:pPr>
               <a:spcBef>
                 <a:spcPts val="1000"/>
               </a:spcBef>
             </a:pPr>
             <a:r>
+              <a:rPr lang="en-US"/>
+              <a:t>Data </a:t>
+            </a:r>
+            <a:r>
               <a:rPr lang="en-US" dirty="0"/>
-              <a:t>Data quality is the foundation — 35 % of effort was cleaning alone </a:t>
+              <a:t>quality is the foundation — 35 % of effort was cleaning alone </a:t>
             </a:r>
           </a:p>
           <a:p>
@@ -6707,6 +6526,164 @@
   <p:cSld>
     <p:spTree>
       <p:nvGrpSpPr>
+        <p:cNvPr id="1" name=""/>
+        <p:cNvGrpSpPr/>
+        <p:nvPr/>
+      </p:nvGrpSpPr>
+      <p:grpSpPr>
+        <a:xfrm>
+          <a:off x="0" y="0"/>
+          <a:ext cx="0" cy="0"/>
+          <a:chOff x="0" y="0"/>
+          <a:chExt cx="0" cy="0"/>
+        </a:xfrm>
+      </p:grpSpPr>
+      <p:sp>
+        <p:nvSpPr>
+          <p:cNvPr id="2" name="Title 1">
+            <a:extLst>
+              <a:ext uri="{FF2B5EF4-FFF2-40B4-BE49-F238E27FC236}">
+                <a16:creationId xmlns:a16="http://schemas.microsoft.com/office/drawing/2014/main" id="{44DD8232-CEB0-5333-15CC-8241C02AC156}"/>
+              </a:ext>
+            </a:extLst>
+          </p:cNvPr>
+          <p:cNvSpPr>
+            <a:spLocks noGrp="1"/>
+          </p:cNvSpPr>
+          <p:nvPr>
+            <p:ph type="title"/>
+          </p:nvPr>
+        </p:nvSpPr>
+        <p:spPr/>
+        <p:txBody>
+          <a:bodyPr>
+            <a:normAutofit/>
+          </a:bodyPr>
+          <a:lstStyle/>
+          <a:p>
+            <a:r>
+              <a:rPr lang="en-US" sz="2000" dirty="0"/>
+              <a:t>Limitations</a:t>
+            </a:r>
+          </a:p>
+        </p:txBody>
+      </p:sp>
+      <p:sp>
+        <p:nvSpPr>
+          <p:cNvPr id="3" name="Text Placeholder 2">
+            <a:extLst>
+              <a:ext uri="{FF2B5EF4-FFF2-40B4-BE49-F238E27FC236}">
+                <a16:creationId xmlns:a16="http://schemas.microsoft.com/office/drawing/2014/main" id="{BDBA7325-6C4D-FB30-667E-AEBAE13D2E1D}"/>
+              </a:ext>
+            </a:extLst>
+          </p:cNvPr>
+          <p:cNvSpPr>
+            <a:spLocks noGrp="1"/>
+          </p:cNvSpPr>
+          <p:nvPr>
+            <p:ph type="body" idx="1"/>
+          </p:nvPr>
+        </p:nvSpPr>
+        <p:spPr/>
+        <p:txBody>
+          <a:bodyPr/>
+          <a:lstStyle/>
+          <a:p>
+            <a:pPr marL="114300" indent="0">
+              <a:lnSpc>
+                <a:spcPct val="150000"/>
+              </a:lnSpc>
+              <a:buNone/>
+            </a:pPr>
+            <a:r>
+              <a:rPr lang="en-US" dirty="0"/>
+              <a:t>No date stamps for sign-up, churn, or billing. This prevents time-to-churn analysis.</a:t>
+            </a:r>
+          </a:p>
+          <a:p>
+            <a:pPr marL="114300" indent="0">
+              <a:lnSpc>
+                <a:spcPct val="150000"/>
+              </a:lnSpc>
+              <a:buNone/>
+            </a:pPr>
+            <a:r>
+              <a:rPr lang="en-US" dirty="0"/>
+              <a:t>Internet service type (Fiber optic) and payment method (Electronic check) correlate with income level.</a:t>
+            </a:r>
+          </a:p>
+          <a:p>
+            <a:pPr marL="114300" indent="0">
+              <a:lnSpc>
+                <a:spcPct val="150000"/>
+              </a:lnSpc>
+              <a:buNone/>
+            </a:pPr>
+            <a:r>
+              <a:rPr lang="en-US" dirty="0"/>
+              <a:t>Very early churners who left before data capture are absent.</a:t>
+            </a:r>
+          </a:p>
+        </p:txBody>
+      </p:sp>
+      <p:sp>
+        <p:nvSpPr>
+          <p:cNvPr id="4" name="Slide Number Placeholder 3">
+            <a:extLst>
+              <a:ext uri="{FF2B5EF4-FFF2-40B4-BE49-F238E27FC236}">
+                <a16:creationId xmlns:a16="http://schemas.microsoft.com/office/drawing/2014/main" id="{1236A76D-D52E-53DE-FF8E-D1EC0B683C4C}"/>
+              </a:ext>
+            </a:extLst>
+          </p:cNvPr>
+          <p:cNvSpPr>
+            <a:spLocks noGrp="1"/>
+          </p:cNvSpPr>
+          <p:nvPr>
+            <p:ph type="sldNum" idx="12"/>
+          </p:nvPr>
+        </p:nvSpPr>
+        <p:spPr/>
+        <p:txBody>
+          <a:bodyPr>
+            <a:normAutofit fontScale="92500" lnSpcReduction="20000"/>
+          </a:bodyPr>
+          <a:lstStyle/>
+          <a:p>
+            <a:pPr marL="0" lvl="0" indent="0" algn="r" rtl="0">
+              <a:spcBef>
+                <a:spcPts val="0"/>
+              </a:spcBef>
+              <a:spcAft>
+                <a:spcPts val="0"/>
+              </a:spcAft>
+              <a:buNone/>
+            </a:pPr>
+            <a:fld id="{00000000-1234-1234-1234-123412341234}" type="slidenum">
+              <a:rPr lang="en" smtClean="0"/>
+              <a:t>13</a:t>
+            </a:fld>
+            <a:endParaRPr lang="en"/>
+          </a:p>
+        </p:txBody>
+      </p:sp>
+    </p:spTree>
+    <p:extLst>
+      <p:ext uri="{BB962C8B-B14F-4D97-AF65-F5344CB8AC3E}">
+        <p14:creationId xmlns:p14="http://schemas.microsoft.com/office/powerpoint/2010/main" val="2466423651"/>
+      </p:ext>
+    </p:extLst>
+  </p:cSld>
+  <p:clrMapOvr>
+    <a:masterClrMapping/>
+  </p:clrMapOvr>
+</p:sld>
+</file>
+
+<file path=ppt/slides/slide14.xml><?xml version="1.0" encoding="utf-8"?>
+<p:sld xmlns:a="http://schemas.openxmlformats.org/drawingml/2006/main" xmlns:r="http://schemas.openxmlformats.org/officeDocument/2006/relationships" xmlns:p="http://schemas.openxmlformats.org/presentationml/2006/main">
+  <p:cSld>
+    <p:spTree>
+      <p:nvGrpSpPr>
         <p:cNvPr id="1" name="Shape 457"/>
         <p:cNvGrpSpPr/>
         <p:nvPr/>
@@ -6740,16 +6717,16 @@
         </p:spPr>
         <p:txBody>
           <a:bodyPr spcFirstLastPara="1" wrap="square" lIns="91425" tIns="91425" rIns="91425" bIns="91425" anchor="ctr" anchorCtr="0">
-            <a:normAutofit fontScale="90000"/>
+            <a:normAutofit/>
           </a:bodyPr>
           <a:lstStyle/>
           <a:p>
             <a:pPr lvl="0"/>
             <a:r>
-              <a:rPr lang="en-US" dirty="0"/>
+              <a:rPr lang="en-US" sz="2000" dirty="0"/>
               <a:t>Next steps</a:t>
             </a:r>
-            <a:endParaRPr dirty="0"/>
+            <a:endParaRPr sz="2000" dirty="0"/>
           </a:p>
         </p:txBody>
       </p:sp>
@@ -6798,7 +6775,7 @@
             </a:pPr>
             <a:r>
               <a:rPr lang="en-US" dirty="0"/>
-              <a:t>A/B test retention offers on model-flagged high-risk customers</a:t>
+              <a:t>Run A/B tests on retention offers for predicted high risk customer to determine the most effective strategy</a:t>
             </a:r>
           </a:p>
           <a:p>
@@ -6814,7 +6791,7 @@
             </a:r>
             <a:r>
               <a:rPr lang="en-US" dirty="0" err="1"/>
-              <a:t>behaviour</a:t>
+              <a:t>behavour</a:t>
             </a:r>
             <a:r>
               <a:rPr lang="en-US" dirty="0"/>
@@ -6871,7 +6848,7 @@
             </a:pPr>
             <a:fld id="{00000000-1234-1234-1234-123412341234}" type="slidenum">
               <a:rPr lang="en"/>
-              <a:t>13</a:t>
+              <a:t>14</a:t>
             </a:fld>
             <a:endParaRPr/>
           </a:p>
@@ -6885,8 +6862,8 @@
         </p:nvGrpSpPr>
         <p:grpSpPr>
           <a:xfrm rot="2699785">
-            <a:off x="482122" y="4029609"/>
-            <a:ext cx="1208946" cy="982653"/>
+            <a:off x="521054" y="3971330"/>
+            <a:ext cx="1029303" cy="946934"/>
             <a:chOff x="2318413" y="2452450"/>
             <a:chExt cx="1067700" cy="867900"/>
           </a:xfrm>
@@ -7020,7 +6997,7 @@
 </p:sld>
 </file>
 
-<file path=ppt/slides/slide14.xml><?xml version="1.0" encoding="utf-8"?>
+<file path=ppt/slides/slide15.xml><?xml version="1.0" encoding="utf-8"?>
 <p:sld xmlns:a="http://schemas.openxmlformats.org/drawingml/2006/main" xmlns:r="http://schemas.openxmlformats.org/officeDocument/2006/relationships" xmlns:p="http://schemas.openxmlformats.org/presentationml/2006/main">
   <p:cSld>
     <p:spTree>
@@ -7073,7 +7050,7 @@
             </a:pPr>
             <a:fld id="{00000000-1234-1234-1234-123412341234}" type="slidenum">
               <a:rPr lang="en"/>
-              <a:t>14</a:t>
+              <a:t>15</a:t>
             </a:fld>
             <a:endParaRPr/>
           </a:p>
@@ -7179,16 +7156,16 @@
         </p:spPr>
         <p:txBody>
           <a:bodyPr spcFirstLastPara="1" wrap="square" lIns="91425" tIns="91425" rIns="91425" bIns="91425" anchor="ctr" anchorCtr="0">
-            <a:normAutofit fontScale="90000"/>
+            <a:normAutofit/>
           </a:bodyPr>
           <a:lstStyle/>
           <a:p>
             <a:pPr lvl="0"/>
             <a:r>
-              <a:rPr lang="en-US" dirty="0"/>
+              <a:rPr lang="en-US" sz="2000" dirty="0"/>
               <a:t>What inspired you to choose this project?</a:t>
             </a:r>
-            <a:endParaRPr b="1" dirty="0">
+            <a:endParaRPr sz="2000" b="1" dirty="0">
               <a:latin typeface="Assistant"/>
               <a:ea typeface="Assistant"/>
               <a:cs typeface="Assistant"/>
@@ -7228,7 +7205,7 @@
           </a:bodyPr>
           <a:lstStyle/>
           <a:p>
-            <a:pPr marL="114300" lvl="0" indent="0" algn="just">
+            <a:pPr marL="114300" indent="0" algn="just">
               <a:lnSpc>
                 <a:spcPct val="150000"/>
               </a:lnSpc>
@@ -7236,17 +7213,6 @@
                 <a:spcPts val="1000"/>
               </a:spcBef>
               <a:buNone/>
-            </a:pPr>
-            <a:endParaRPr lang="en-US" dirty="0"/>
-          </a:p>
-          <a:p>
-            <a:pPr algn="just">
-              <a:lnSpc>
-                <a:spcPct val="150000"/>
-              </a:lnSpc>
-              <a:spcBef>
-                <a:spcPts val="1000"/>
-              </a:spcBef>
             </a:pPr>
             <a:r>
               <a:rPr lang="en-US" dirty="0"/>
@@ -7254,13 +7220,14 @@
             </a:r>
           </a:p>
           <a:p>
-            <a:pPr algn="just">
+            <a:pPr marL="114300" indent="0" algn="just">
               <a:lnSpc>
                 <a:spcPct val="150000"/>
               </a:lnSpc>
               <a:spcBef>
                 <a:spcPts val="1000"/>
               </a:spcBef>
+              <a:buNone/>
             </a:pPr>
             <a:r>
               <a:rPr lang="en-US" dirty="0"/>
@@ -7268,13 +7235,14 @@
             </a:r>
           </a:p>
           <a:p>
-            <a:pPr algn="just">
+            <a:pPr marL="114300" indent="0" algn="just">
               <a:lnSpc>
                 <a:spcPct val="150000"/>
               </a:lnSpc>
               <a:spcBef>
                 <a:spcPts val="1000"/>
               </a:spcBef>
+              <a:buNone/>
             </a:pPr>
             <a:r>
               <a:rPr lang="en-US" dirty="0"/>
@@ -7629,16 +7597,16 @@
         </p:spPr>
         <p:txBody>
           <a:bodyPr spcFirstLastPara="1" wrap="square" lIns="91425" tIns="91425" rIns="91425" bIns="91425" anchor="ctr" anchorCtr="0">
-            <a:normAutofit fontScale="90000"/>
+            <a:normAutofit/>
           </a:bodyPr>
           <a:lstStyle/>
           <a:p>
             <a:pPr lvl="0"/>
             <a:r>
-              <a:rPr lang="en-US" dirty="0"/>
+              <a:rPr lang="en-US" sz="2000" dirty="0"/>
               <a:t>What did you do?</a:t>
             </a:r>
-            <a:endParaRPr b="1" dirty="0">
+            <a:endParaRPr sz="2000" b="1" dirty="0">
               <a:latin typeface="Assistant"/>
               <a:ea typeface="Assistant"/>
               <a:cs typeface="Assistant"/>
@@ -8394,16 +8362,16 @@
         </p:spPr>
         <p:txBody>
           <a:bodyPr spcFirstLastPara="1" wrap="square" lIns="91425" tIns="91425" rIns="91425" bIns="91425" anchor="ctr" anchorCtr="0">
-            <a:normAutofit fontScale="90000"/>
+            <a:normAutofit/>
           </a:bodyPr>
           <a:lstStyle/>
           <a:p>
             <a:pPr lvl="0"/>
             <a:r>
-              <a:rPr lang="en-US" dirty="0"/>
+              <a:rPr lang="en-US" sz="2000" dirty="0"/>
               <a:t>Tools and libraries used</a:t>
             </a:r>
-            <a:endParaRPr b="1" dirty="0">
+            <a:endParaRPr sz="2000" b="1" dirty="0">
               <a:latin typeface="Assistant"/>
               <a:ea typeface="Assistant"/>
               <a:cs typeface="Assistant"/>
@@ -8887,11 +8855,7 @@
             <a:pPr lvl="0"/>
             <a:r>
               <a:rPr lang="en-US" sz="2000" dirty="0"/>
-              <a:t>Customer profile and churn </a:t>
-            </a:r>
-            <a:r>
-              <a:rPr lang="en-US" sz="2000" dirty="0" err="1"/>
-              <a:t>behaviour</a:t>
+              <a:t>Customer profile and churn behaviour</a:t>
             </a:r>
             <a:endParaRPr sz="2000" b="1" dirty="0">
               <a:latin typeface="Assistant"/>
@@ -9089,12 +9053,12 @@
         <p:spPr/>
         <p:txBody>
           <a:bodyPr>
-            <a:normAutofit fontScale="90000"/>
+            <a:normAutofit/>
           </a:bodyPr>
           <a:lstStyle/>
           <a:p>
             <a:r>
-              <a:rPr lang="en-US" dirty="0"/>
+              <a:rPr lang="en-US" sz="2000" dirty="0"/>
               <a:t>Relationship between the numeric variable</a:t>
             </a:r>
           </a:p>
@@ -9476,16 +9440,16 @@
         </p:spPr>
         <p:txBody>
           <a:bodyPr spcFirstLastPara="1" wrap="square" lIns="91425" tIns="91425" rIns="91425" bIns="91425" anchor="ctr" anchorCtr="0">
-            <a:normAutofit fontScale="90000"/>
+            <a:normAutofit/>
           </a:bodyPr>
           <a:lstStyle/>
           <a:p>
             <a:pPr lvl="0"/>
             <a:r>
-              <a:rPr lang="en-US" dirty="0"/>
+              <a:rPr lang="en-US" sz="2000" dirty="0"/>
               <a:t>Contract type drives churn</a:t>
             </a:r>
-            <a:endParaRPr b="1" dirty="0">
+            <a:endParaRPr sz="2000" b="1" dirty="0">
               <a:latin typeface="Assistant"/>
               <a:ea typeface="Assistant"/>
               <a:cs typeface="Assistant"/>
@@ -9950,12 +9914,12 @@
         </p:spPr>
         <p:txBody>
           <a:bodyPr>
-            <a:normAutofit fontScale="90000"/>
+            <a:normAutofit/>
           </a:bodyPr>
           <a:lstStyle/>
           <a:p>
             <a:r>
-              <a:rPr lang="en-US" dirty="0"/>
+              <a:rPr lang="en-US" sz="2000" dirty="0"/>
               <a:t>Full model comparison </a:t>
             </a:r>
           </a:p>
@@ -10333,7 +10297,15 @@
             </a:br>
             <a:r>
               <a:rPr lang="en-US" sz="2000" dirty="0"/>
-              <a:t>Confusion matrices of the top three models</a:t>
+              <a:t>Confusion matrices of </a:t>
+            </a:r>
+            <a:r>
+              <a:rPr lang="en-US" sz="2000" dirty="0" err="1"/>
+              <a:t>Xgboost</a:t>
+            </a:r>
+            <a:r>
+              <a:rPr lang="en-US" sz="2000" dirty="0"/>
+              <a:t> optimized</a:t>
             </a:r>
             <a:br>
               <a:rPr lang="en-US" sz="2000" dirty="0"/>
@@ -10345,37 +10317,6 @@
           </a:p>
         </p:txBody>
       </p:sp>
-      <p:pic>
-        <p:nvPicPr>
-          <p:cNvPr id="2" name="Picture 1">
-            <a:extLst>
-              <a:ext uri="{FF2B5EF4-FFF2-40B4-BE49-F238E27FC236}">
-                <a16:creationId xmlns:a16="http://schemas.microsoft.com/office/drawing/2014/main" id="{F17063A0-1668-E1C1-15DC-00A9D37F2D53}"/>
-              </a:ext>
-            </a:extLst>
-          </p:cNvPr>
-          <p:cNvPicPr>
-            <a:picLocks noChangeAspect="1"/>
-          </p:cNvPicPr>
-          <p:nvPr/>
-        </p:nvPicPr>
-        <p:blipFill>
-          <a:blip r:embed="rId3"/>
-          <a:srcRect t="8895" r="1219"/>
-          <a:stretch>
-            <a:fillRect/>
-          </a:stretch>
-        </p:blipFill>
-        <p:spPr>
-          <a:xfrm>
-            <a:off x="546442" y="915600"/>
-            <a:ext cx="7677615" cy="1943278"/>
-          </a:xfrm>
-          <a:prstGeom prst="rect">
-            <a:avLst/>
-          </a:prstGeom>
-        </p:spPr>
-      </p:pic>
       <p:grpSp>
         <p:nvGrpSpPr>
           <p:cNvPr id="4" name="Google Shape;448;p42">
@@ -10624,8 +10565,8 @@
         </p:nvSpPr>
         <p:spPr>
           <a:xfrm>
-            <a:off x="1371600" y="3646448"/>
-            <a:ext cx="5553307" cy="1169551"/>
+            <a:off x="1354238" y="3761773"/>
+            <a:ext cx="5605393" cy="1200329"/>
           </a:xfrm>
           <a:prstGeom prst="rect">
             <a:avLst/>
@@ -10639,30 +10580,79 @@
           <a:lstStyle/>
           <a:p>
             <a:r>
-              <a:rPr lang="en-US" dirty="0"/>
-              <a:t>		Predicted: No Churn    Predicted: Churn</a:t>
+              <a:rPr lang="en-US" sz="1200" dirty="0">
+                <a:latin typeface=""/>
+              </a:rPr>
+              <a:t>			</a:t>
             </a:r>
           </a:p>
           <a:p>
-            <a:endParaRPr lang="en-US" dirty="0"/>
+            <a:r>
+              <a:rPr lang="en-US" sz="1200" dirty="0">
+                <a:latin typeface=""/>
+              </a:rPr>
+              <a:t>		Predicted: No Churn    	Predicted: Churn</a:t>
+            </a:r>
+          </a:p>
+          <a:p>
+            <a:endParaRPr lang="en-US" sz="1200" dirty="0">
+              <a:latin typeface=""/>
+            </a:endParaRPr>
           </a:p>
           <a:p>
             <a:r>
-              <a:rPr lang="en-US" dirty="0"/>
+              <a:rPr lang="en-US" sz="1200" dirty="0">
+                <a:latin typeface=""/>
+              </a:rPr>
               <a:t>Actual: No Churn      		  TN                    	FP</a:t>
             </a:r>
           </a:p>
           <a:p>
-            <a:endParaRPr lang="en-US" dirty="0"/>
+            <a:endParaRPr lang="en-US" sz="1200" dirty="0">
+              <a:latin typeface=""/>
+            </a:endParaRPr>
           </a:p>
           <a:p>
             <a:r>
-              <a:rPr lang="en-US" dirty="0"/>
+              <a:rPr lang="en-US" sz="1200" dirty="0">
+                <a:latin typeface=""/>
+              </a:rPr>
               <a:t>Actual: Churn       		  FN                    	TP</a:t>
             </a:r>
           </a:p>
         </p:txBody>
       </p:sp>
+      <p:pic>
+        <p:nvPicPr>
+          <p:cNvPr id="6" name="Picture 5">
+            <a:extLst>
+              <a:ext uri="{FF2B5EF4-FFF2-40B4-BE49-F238E27FC236}">
+                <a16:creationId xmlns:a16="http://schemas.microsoft.com/office/drawing/2014/main" id="{C40643CD-0BBE-B11D-3385-BBDB08672659}"/>
+              </a:ext>
+            </a:extLst>
+          </p:cNvPr>
+          <p:cNvPicPr>
+            <a:picLocks noChangeAspect="1"/>
+          </p:cNvPicPr>
+          <p:nvPr/>
+        </p:nvPicPr>
+        <p:blipFill>
+          <a:blip r:embed="rId3"/>
+          <a:srcRect t="13367" r="4348" b="3420"/>
+          <a:stretch>
+            <a:fillRect/>
+          </a:stretch>
+        </p:blipFill>
+        <p:spPr>
+          <a:xfrm>
+            <a:off x="2237368" y="879676"/>
+            <a:ext cx="4295763" cy="2882097"/>
+          </a:xfrm>
+          <a:prstGeom prst="rect">
+            <a:avLst/>
+          </a:prstGeom>
+        </p:spPr>
+      </p:pic>
     </p:spTree>
     <p:extLst>
       <p:ext uri="{BB962C8B-B14F-4D97-AF65-F5344CB8AC3E}">

</xml_diff>